<commit_message>
Restyle event map slide to match approved deck
Co-authored-by: arena-agent <297053741+arena-agent@users.noreply.github.com>
</commit_message>
<xml_diff>
--- a/documents/ubs-event-map-slide.pptx
+++ b/documents/ubs-event-map-slide.pptx
@@ -3084,7 +3084,7 @@
     <p:bg>
       <p:bgPr>
         <a:solidFill>
-          <a:srgbClr val="F4F7FA"/>
+          <a:srgbClr val="F7F7F3"/>
         </a:solidFill>
         <a:effectLst/>
       </p:bgPr>
@@ -3096,16 +3096,40 @@
         <p:nvPr/>
       </p:nvGrpSpPr>
       <p:grpSpPr/>
-      <p:sp>
-        <p:nvSpPr>
-          <p:cNvPr id="2" name="TextBox 1"/>
+      <p:pic>
+        <p:nvPicPr>
+          <p:cNvPr id="2" name="Picture 1" descr="ubs-logo-slide.png"/>
+          <p:cNvPicPr>
+            <a:picLocks noChangeAspect="1"/>
+          </p:cNvPicPr>
+          <p:nvPr/>
+        </p:nvPicPr>
+        <p:blipFill>
+          <a:blip r:embed="rId2"/>
+          <a:stretch>
+            <a:fillRect/>
+          </a:stretch>
+        </p:blipFill>
+        <p:spPr>
+          <a:xfrm>
+            <a:off x="365760" y="164592"/>
+            <a:ext cx="1399032" cy="493776"/>
+          </a:xfrm>
+          <a:prstGeom prst="rect">
+            <a:avLst/>
+          </a:prstGeom>
+        </p:spPr>
+      </p:pic>
+      <p:sp>
+        <p:nvSpPr>
+          <p:cNvPr id="3" name="TextBox 2"/>
           <p:cNvSpPr txBox="1"/>
           <p:nvPr/>
         </p:nvSpPr>
         <p:spPr>
           <a:xfrm>
-            <a:off x="512064" y="210312"/>
-            <a:ext cx="4572000" cy="201168"/>
+            <a:off x="1993392" y="164592"/>
+            <a:ext cx="8138160" cy="283464"/>
           </a:xfrm>
           <a:prstGeom prst="rect">
             <a:avLst/>
@@ -3127,27 +3151,27 @@
               </a:spcAft>
             </a:pPr>
             <a:r>
-              <a:rPr sz="900" b="1">
+              <a:rPr sz="1750" b="1">
                 <a:solidFill>
-                  <a:srgbClr val="139B96"/>
+                  <a:srgbClr val="18232B"/>
                 </a:solidFill>
                 <a:latin typeface="Arial"/>
               </a:rPr>
-              <a:t>RISK CASE STUDY  /  EUROPE</a:t>
-            </a:r>
-          </a:p>
-        </p:txBody>
-      </p:sp>
-      <p:sp>
-        <p:nvSpPr>
-          <p:cNvPr id="3" name="TextBox 2"/>
+              <a:t>UBS INVESTMENT BANK  |  2011</a:t>
+            </a:r>
+          </a:p>
+        </p:txBody>
+      </p:sp>
+      <p:sp>
+        <p:nvSpPr>
+          <p:cNvPr id="4" name="TextBox 3"/>
           <p:cNvSpPr txBox="1"/>
           <p:nvPr/>
         </p:nvSpPr>
         <p:spPr>
           <a:xfrm>
-            <a:off x="512064" y="438912"/>
-            <a:ext cx="7315200" cy="393192"/>
+            <a:off x="1993392" y="448056"/>
+            <a:ext cx="8138160" cy="201168"/>
           </a:xfrm>
           <a:prstGeom prst="rect">
             <a:avLst/>
@@ -3169,27 +3193,27 @@
               </a:spcAft>
             </a:pPr>
             <a:r>
-              <a:rPr sz="2400" b="1">
+              <a:rPr sz="1050" b="1">
                 <a:solidFill>
-                  <a:srgbClr val="173044"/>
+                  <a:srgbClr val="C82036"/>
                 </a:solidFill>
                 <a:latin typeface="Arial"/>
               </a:rPr>
-              <a:t>MAJOR EUROPEAN TRADING LOSS EVENTS</a:t>
-            </a:r>
-          </a:p>
-        </p:txBody>
-      </p:sp>
-      <p:sp>
-        <p:nvSpPr>
-          <p:cNvPr id="4" name="TextBox 3"/>
+              <a:t>EUROPEAN TRADING-LOSS BENCHMARKS</a:t>
+            </a:r>
+          </a:p>
+        </p:txBody>
+      </p:sp>
+      <p:sp>
+        <p:nvSpPr>
+          <p:cNvPr id="5" name="TextBox 4"/>
           <p:cNvSpPr txBox="1"/>
           <p:nvPr/>
         </p:nvSpPr>
         <p:spPr>
           <a:xfrm>
-            <a:off x="521207" y="896112"/>
-            <a:ext cx="7680960" cy="219456"/>
+            <a:off x="1993392" y="685800"/>
+            <a:ext cx="8138160" cy="164592"/>
           </a:xfrm>
           <a:prstGeom prst="rect">
             <a:avLst/>
@@ -3211,38 +3235,60 @@
               </a:spcAft>
             </a:pPr>
             <a:r>
-              <a:rPr sz="1050" b="0">
+              <a:rPr sz="830" b="0">
                 <a:solidFill>
-                  <a:srgbClr val="647684"/>
+                  <a:srgbClr val="737B80"/>
                 </a:solidFill>
                 <a:latin typeface="Arial"/>
               </a:rPr>
-              <a:t>Selected benchmark trading-loss events relevant to the UBS 2011 case</a:t>
-            </a:r>
-          </a:p>
-        </p:txBody>
-      </p:sp>
-      <p:sp>
-        <p:nvSpPr>
-          <p:cNvPr id="5" name="Rounded Rectangle 4"/>
+              <a:t>Treasury Committee  /  incident overview</a:t>
+            </a:r>
+          </a:p>
+        </p:txBody>
+      </p:sp>
+      <p:pic>
+        <p:nvPicPr>
+          <p:cNvPr id="6" name="Picture 5" descr="skema-logo.png"/>
+          <p:cNvPicPr>
+            <a:picLocks noChangeAspect="1"/>
+          </p:cNvPicPr>
+          <p:nvPr/>
+        </p:nvPicPr>
+        <p:blipFill>
+          <a:blip r:embed="rId3"/>
+          <a:stretch>
+            <a:fillRect/>
+          </a:stretch>
+        </p:blipFill>
+        <p:spPr>
+          <a:xfrm>
+            <a:off x="11173968" y="146304"/>
+            <a:ext cx="539496" cy="539496"/>
+          </a:xfrm>
+          <a:prstGeom prst="rect">
+            <a:avLst/>
+          </a:prstGeom>
+        </p:spPr>
+      </p:pic>
+      <p:sp>
+        <p:nvSpPr>
+          <p:cNvPr id="7" name="Rectangle 6"/>
           <p:cNvSpPr/>
           <p:nvPr/>
         </p:nvSpPr>
         <p:spPr>
           <a:xfrm>
-            <a:off x="411480" y="1307592"/>
-            <a:ext cx="6903720" cy="5175504"/>
-          </a:xfrm>
-          <a:prstGeom prst="roundRect">
+            <a:off x="365760" y="905256"/>
+            <a:ext cx="11457432" cy="10972"/>
+          </a:xfrm>
+          <a:prstGeom prst="rect">
             <a:avLst/>
           </a:prstGeom>
           <a:solidFill>
-            <a:srgbClr val="FFFFFF"/>
+            <a:srgbClr val="C9CDCA"/>
           </a:solidFill>
-          <a:ln w="10160">
-            <a:solidFill>
-              <a:srgbClr val="E1E8EE"/>
-            </a:solidFill>
+          <a:ln>
+            <a:noFill/>
           </a:ln>
         </p:spPr>
         <p:style>
@@ -3267,50 +3313,110 @@
           </a:p>
         </p:txBody>
       </p:sp>
-      <p:pic>
-        <p:nvPicPr>
-          <p:cNvPr id="6" name="Picture 5" descr="ubs-event-map-approved.png"/>
-          <p:cNvPicPr>
-            <a:picLocks noChangeAspect="1"/>
-          </p:cNvPicPr>
+      <p:sp>
+        <p:nvSpPr>
+          <p:cNvPr id="8" name="TextBox 7"/>
+          <p:cNvSpPr txBox="1"/>
           <p:nvPr/>
-        </p:nvPicPr>
-        <p:blipFill>
-          <a:blip r:embed="rId2"/>
-          <a:stretch>
-            <a:fillRect/>
-          </a:stretch>
-        </p:blipFill>
-        <p:spPr>
-          <a:xfrm>
-            <a:off x="502920" y="1371600"/>
-            <a:ext cx="6720840" cy="5047488"/>
+        </p:nvSpPr>
+        <p:spPr>
+          <a:xfrm>
+            <a:off x="393192" y="960120"/>
+            <a:ext cx="5577840" cy="182880"/>
           </a:xfrm>
           <a:prstGeom prst="rect">
             <a:avLst/>
           </a:prstGeom>
-        </p:spPr>
-      </p:pic>
-      <p:sp>
-        <p:nvSpPr>
-          <p:cNvPr id="7" name="Rounded Rectangle 6"/>
+          <a:noFill/>
+        </p:spPr>
+        <p:txBody>
+          <a:bodyPr wrap="none" lIns="0" rIns="0" tIns="0" bIns="0" anchor="ctr">
+            <a:spAutoFit/>
+          </a:bodyPr>
+          <a:lstStyle/>
+          <a:p>
+            <a:pPr algn="l">
+              <a:spcBef>
+                <a:spcPts val="0"/>
+              </a:spcBef>
+              <a:spcAft>
+                <a:spcPts val="0"/>
+              </a:spcAft>
+            </a:pPr>
+            <a:r>
+              <a:rPr sz="770" b="1">
+                <a:solidFill>
+                  <a:srgbClr val="737B80"/>
+                </a:solidFill>
+                <a:latin typeface="Arial"/>
+              </a:rPr>
+              <a:t>EUROPEAN LOSS EVENTS  /  MAP &amp; BENCHMARKS</a:t>
+            </a:r>
+          </a:p>
+        </p:txBody>
+      </p:sp>
+      <p:sp>
+        <p:nvSpPr>
+          <p:cNvPr id="9" name="TextBox 8"/>
+          <p:cNvSpPr txBox="1"/>
+          <p:nvPr/>
+        </p:nvSpPr>
+        <p:spPr>
+          <a:xfrm>
+            <a:off x="6949440" y="960120"/>
+            <a:ext cx="4800600" cy="182880"/>
+          </a:xfrm>
+          <a:prstGeom prst="rect">
+            <a:avLst/>
+          </a:prstGeom>
+          <a:noFill/>
+        </p:spPr>
+        <p:txBody>
+          <a:bodyPr wrap="none" lIns="0" rIns="0" tIns="0" bIns="0" anchor="ctr">
+            <a:spAutoFit/>
+          </a:bodyPr>
+          <a:lstStyle/>
+          <a:p>
+            <a:pPr algn="r">
+              <a:spcBef>
+                <a:spcPts val="0"/>
+              </a:spcBef>
+              <a:spcAft>
+                <a:spcPts val="0"/>
+              </a:spcAft>
+            </a:pPr>
+            <a:r>
+              <a:rPr sz="770" b="1">
+                <a:solidFill>
+                  <a:srgbClr val="737B80"/>
+                </a:solidFill>
+                <a:latin typeface="Arial"/>
+              </a:rPr>
+              <a:t>HISTORICAL CASES  ·  LOSS FIGURES AS LABELLED</a:t>
+            </a:r>
+          </a:p>
+        </p:txBody>
+      </p:sp>
+      <p:sp>
+        <p:nvSpPr>
+          <p:cNvPr id="10" name="Rectangle 9"/>
           <p:cNvSpPr/>
           <p:nvPr/>
         </p:nvSpPr>
         <p:spPr>
           <a:xfrm>
-            <a:off x="7498079" y="1307592"/>
-            <a:ext cx="4279392" cy="5175504"/>
-          </a:xfrm>
-          <a:prstGeom prst="roundRect">
+            <a:off x="384048" y="1197864"/>
+            <a:ext cx="6583680" cy="4965192"/>
+          </a:xfrm>
+          <a:prstGeom prst="rect">
             <a:avLst/>
           </a:prstGeom>
           <a:solidFill>
-            <a:srgbClr val="FFFFFF"/>
+            <a:srgbClr val="101315"/>
           </a:solidFill>
           <a:ln w="10160">
             <a:solidFill>
-              <a:srgbClr val="E1E8EE"/>
+              <a:srgbClr val="30373B"/>
             </a:solidFill>
           </a:ln>
         </p:spPr>
@@ -3338,109 +3444,23 @@
       </p:sp>
       <p:sp>
         <p:nvSpPr>
-          <p:cNvPr id="8" name="TextBox 7"/>
-          <p:cNvSpPr txBox="1"/>
+          <p:cNvPr id="11" name="Rectangle 10"/>
+          <p:cNvSpPr/>
           <p:nvPr/>
         </p:nvSpPr>
         <p:spPr>
           <a:xfrm>
-            <a:off x="7754112" y="1581912"/>
-            <a:ext cx="3566160" cy="201168"/>
+            <a:off x="384048" y="1197864"/>
+            <a:ext cx="6583680" cy="41148"/>
           </a:xfrm>
           <a:prstGeom prst="rect">
             <a:avLst/>
           </a:prstGeom>
-          <a:noFill/>
-        </p:spPr>
-        <p:txBody>
-          <a:bodyPr wrap="none" lIns="0" rIns="0" tIns="0" bIns="0" anchor="ctr">
-            <a:spAutoFit/>
-          </a:bodyPr>
-          <a:lstStyle/>
-          <a:p>
-            <a:pPr algn="l">
-              <a:spcBef>
-                <a:spcPts val="0"/>
-              </a:spcBef>
-              <a:spcAft>
-                <a:spcPts val="0"/>
-              </a:spcAft>
-            </a:pPr>
-            <a:r>
-              <a:rPr sz="900" b="1">
-                <a:solidFill>
-                  <a:srgbClr val="139B96"/>
-                </a:solidFill>
-                <a:latin typeface="Arial"/>
-              </a:rPr>
-              <a:t>BENCHMARK CASES</a:t>
-            </a:r>
-          </a:p>
-        </p:txBody>
-      </p:sp>
-      <p:sp>
-        <p:nvSpPr>
-          <p:cNvPr id="9" name="TextBox 8"/>
-          <p:cNvSpPr txBox="1"/>
-          <p:nvPr/>
-        </p:nvSpPr>
-        <p:spPr>
-          <a:xfrm>
-            <a:off x="7754112" y="1819656"/>
-            <a:ext cx="3749039" cy="329184"/>
-          </a:xfrm>
-          <a:prstGeom prst="rect">
-            <a:avLst/>
-          </a:prstGeom>
-          <a:noFill/>
-        </p:spPr>
-        <p:txBody>
-          <a:bodyPr wrap="none" lIns="0" rIns="0" tIns="0" bIns="0" anchor="ctr">
-            <a:spAutoFit/>
-          </a:bodyPr>
-          <a:lstStyle/>
-          <a:p>
-            <a:pPr algn="l">
-              <a:spcBef>
-                <a:spcPts val="0"/>
-              </a:spcBef>
-              <a:spcAft>
-                <a:spcPts val="0"/>
-              </a:spcAft>
-            </a:pPr>
-            <a:r>
-              <a:rPr sz="1600" b="1">
-                <a:solidFill>
-                  <a:srgbClr val="173044"/>
-                </a:solidFill>
-                <a:latin typeface="Arial"/>
-              </a:rPr>
-              <a:t>Three historic losses</a:t>
-            </a:r>
-          </a:p>
-        </p:txBody>
-      </p:sp>
-      <p:sp>
-        <p:nvSpPr>
-          <p:cNvPr id="10" name="Rounded Rectangle 9"/>
-          <p:cNvSpPr/>
-          <p:nvPr/>
-        </p:nvSpPr>
-        <p:spPr>
-          <a:xfrm>
-            <a:off x="7754112" y="2286000"/>
-            <a:ext cx="3767328" cy="932688"/>
-          </a:xfrm>
-          <a:prstGeom prst="roundRect">
-            <a:avLst/>
-          </a:prstGeom>
           <a:solidFill>
-            <a:srgbClr val="FFFFFF"/>
+            <a:srgbClr val="00A985"/>
           </a:solidFill>
-          <a:ln w="10160">
-            <a:solidFill>
-              <a:srgbClr val="E1E8EE"/>
-            </a:solidFill>
+          <a:ln>
+            <a:noFill/>
           </a:ln>
         </p:spPr>
         <p:style>
@@ -3465,25 +3485,51 @@
           </a:p>
         </p:txBody>
       </p:sp>
-      <p:sp>
-        <p:nvSpPr>
-          <p:cNvPr id="11" name="Rounded Rectangle 10"/>
+      <p:pic>
+        <p:nvPicPr>
+          <p:cNvPr id="12" name="Picture 11" descr="ubs-event-map-approved.png"/>
+          <p:cNvPicPr>
+            <a:picLocks noChangeAspect="1"/>
+          </p:cNvPicPr>
+          <p:nvPr/>
+        </p:nvPicPr>
+        <p:blipFill>
+          <a:blip r:embed="rId4"/>
+          <a:stretch>
+            <a:fillRect/>
+          </a:stretch>
+        </p:blipFill>
+        <p:spPr>
+          <a:xfrm>
+            <a:off x="448056" y="1271016"/>
+            <a:ext cx="6393425" cy="4800600"/>
+          </a:xfrm>
+          <a:prstGeom prst="rect">
+            <a:avLst/>
+          </a:prstGeom>
+        </p:spPr>
+      </p:pic>
+      <p:sp>
+        <p:nvSpPr>
+          <p:cNvPr id="13" name="Rectangle 12"/>
           <p:cNvSpPr/>
           <p:nvPr/>
         </p:nvSpPr>
         <p:spPr>
           <a:xfrm>
-            <a:off x="7900416" y="2468880"/>
-            <a:ext cx="50292" cy="557784"/>
-          </a:xfrm>
-          <a:prstGeom prst="roundRect">
+            <a:off x="7114032" y="1197864"/>
+            <a:ext cx="4709160" cy="4965192"/>
+          </a:xfrm>
+          <a:prstGeom prst="rect">
             <a:avLst/>
           </a:prstGeom>
           <a:solidFill>
-            <a:srgbClr val="A77A00"/>
+            <a:srgbClr val="101315"/>
           </a:solidFill>
-          <a:ln>
-            <a:noFill/>
+          <a:ln w="10160">
+            <a:solidFill>
+              <a:srgbClr val="30373B"/>
+            </a:solidFill>
           </a:ln>
         </p:spPr>
         <p:style>
@@ -3510,151 +3556,23 @@
       </p:sp>
       <p:sp>
         <p:nvSpPr>
-          <p:cNvPr id="12" name="TextBox 11"/>
-          <p:cNvSpPr txBox="1"/>
+          <p:cNvPr id="14" name="Rectangle 13"/>
+          <p:cNvSpPr/>
           <p:nvPr/>
         </p:nvSpPr>
         <p:spPr>
           <a:xfrm>
-            <a:off x="8065008" y="2377440"/>
-            <a:ext cx="2697480" cy="246888"/>
+            <a:off x="7114032" y="1197864"/>
+            <a:ext cx="4709160" cy="41148"/>
           </a:xfrm>
           <a:prstGeom prst="rect">
             <a:avLst/>
           </a:prstGeom>
-          <a:noFill/>
-        </p:spPr>
-        <p:txBody>
-          <a:bodyPr wrap="none" lIns="0" rIns="0" tIns="0" bIns="0" anchor="ctr">
-            <a:spAutoFit/>
-          </a:bodyPr>
-          <a:lstStyle/>
-          <a:p>
-            <a:pPr algn="l">
-              <a:spcBef>
-                <a:spcPts val="0"/>
-              </a:spcBef>
-              <a:spcAft>
-                <a:spcPts val="0"/>
-              </a:spcAft>
-            </a:pPr>
-            <a:r>
-              <a:rPr sz="1250" b="1">
-                <a:solidFill>
-                  <a:srgbClr val="173044"/>
-                </a:solidFill>
-                <a:latin typeface="Arial"/>
-              </a:rPr>
-              <a:t>BARINGS</a:t>
-            </a:r>
-          </a:p>
-        </p:txBody>
-      </p:sp>
-      <p:sp>
-        <p:nvSpPr>
-          <p:cNvPr id="13" name="TextBox 12"/>
-          <p:cNvSpPr txBox="1"/>
-          <p:nvPr/>
-        </p:nvSpPr>
-        <p:spPr>
-          <a:xfrm>
-            <a:off x="10762488" y="2377440"/>
-            <a:ext cx="548640" cy="246888"/>
-          </a:xfrm>
-          <a:prstGeom prst="rect">
-            <a:avLst/>
-          </a:prstGeom>
-          <a:noFill/>
-        </p:spPr>
-        <p:txBody>
-          <a:bodyPr wrap="none" lIns="0" rIns="0" tIns="0" bIns="0" anchor="ctr">
-            <a:spAutoFit/>
-          </a:bodyPr>
-          <a:lstStyle/>
-          <a:p>
-            <a:pPr algn="r">
-              <a:spcBef>
-                <a:spcPts val="0"/>
-              </a:spcBef>
-              <a:spcAft>
-                <a:spcPts val="0"/>
-              </a:spcAft>
-            </a:pPr>
-            <a:r>
-              <a:rPr sz="950" b="1">
-                <a:solidFill>
-                  <a:srgbClr val="A77A00"/>
-                </a:solidFill>
-                <a:latin typeface="Arial"/>
-              </a:rPr>
-              <a:t>1995</a:t>
-            </a:r>
-          </a:p>
-        </p:txBody>
-      </p:sp>
-      <p:sp>
-        <p:nvSpPr>
-          <p:cNvPr id="14" name="TextBox 13"/>
-          <p:cNvSpPr txBox="1"/>
-          <p:nvPr/>
-        </p:nvSpPr>
-        <p:spPr>
-          <a:xfrm>
-            <a:off x="8065008" y="2688336"/>
-            <a:ext cx="2103120" cy="384048"/>
-          </a:xfrm>
-          <a:prstGeom prst="rect">
-            <a:avLst/>
-          </a:prstGeom>
-          <a:noFill/>
-        </p:spPr>
-        <p:txBody>
-          <a:bodyPr wrap="none" lIns="0" rIns="0" tIns="0" bIns="0" anchor="ctr">
-            <a:spAutoFit/>
-          </a:bodyPr>
-          <a:lstStyle/>
-          <a:p>
-            <a:pPr algn="l">
-              <a:spcBef>
-                <a:spcPts val="0"/>
-              </a:spcBef>
-              <a:spcAft>
-                <a:spcPts val="0"/>
-              </a:spcAft>
-            </a:pPr>
-            <a:r>
-              <a:rPr sz="1900" b="1">
-                <a:solidFill>
-                  <a:srgbClr val="A77A00"/>
-                </a:solidFill>
-                <a:latin typeface="Arial"/>
-              </a:rPr>
-              <a:t>USD -1.4bn</a:t>
-            </a:r>
-          </a:p>
-        </p:txBody>
-      </p:sp>
-      <p:sp>
-        <p:nvSpPr>
-          <p:cNvPr id="15" name="Rounded Rectangle 14"/>
-          <p:cNvSpPr/>
-          <p:nvPr/>
-        </p:nvSpPr>
-        <p:spPr>
-          <a:xfrm>
-            <a:off x="7754112" y="3346704"/>
-            <a:ext cx="3767328" cy="932688"/>
-          </a:xfrm>
-          <a:prstGeom prst="roundRect">
-            <a:avLst/>
-          </a:prstGeom>
           <a:solidFill>
-            <a:srgbClr val="FFFFFF"/>
+            <a:srgbClr val="C82036"/>
           </a:solidFill>
-          <a:ln w="10160">
-            <a:solidFill>
-              <a:srgbClr val="E1E8EE"/>
-            </a:solidFill>
+          <a:ln>
+            <a:noFill/>
           </a:ln>
         </p:spPr>
         <p:style>
@@ -3681,20 +3599,104 @@
       </p:sp>
       <p:sp>
         <p:nvSpPr>
-          <p:cNvPr id="16" name="Rounded Rectangle 15"/>
+          <p:cNvPr id="15" name="TextBox 14"/>
+          <p:cNvSpPr txBox="1"/>
+          <p:nvPr/>
+        </p:nvSpPr>
+        <p:spPr>
+          <a:xfrm>
+            <a:off x="7306056" y="1426464"/>
+            <a:ext cx="4343400" cy="228600"/>
+          </a:xfrm>
+          <a:prstGeom prst="rect">
+            <a:avLst/>
+          </a:prstGeom>
+          <a:noFill/>
+        </p:spPr>
+        <p:txBody>
+          <a:bodyPr wrap="none" lIns="0" rIns="0" tIns="0" bIns="0" anchor="ctr">
+            <a:spAutoFit/>
+          </a:bodyPr>
+          <a:lstStyle/>
+          <a:p>
+            <a:pPr algn="l">
+              <a:spcBef>
+                <a:spcPts val="0"/>
+              </a:spcBef>
+              <a:spcAft>
+                <a:spcPts val="0"/>
+              </a:spcAft>
+            </a:pPr>
+            <a:r>
+              <a:rPr sz="1100" b="1">
+                <a:solidFill>
+                  <a:srgbClr val="F7F8F6"/>
+                </a:solidFill>
+                <a:latin typeface="Arial"/>
+              </a:rPr>
+              <a:t>BENCHMARK LOSS EVENTS</a:t>
+            </a:r>
+          </a:p>
+        </p:txBody>
+      </p:sp>
+      <p:sp>
+        <p:nvSpPr>
+          <p:cNvPr id="16" name="TextBox 15"/>
+          <p:cNvSpPr txBox="1"/>
+          <p:nvPr/>
+        </p:nvSpPr>
+        <p:spPr>
+          <a:xfrm>
+            <a:off x="7306056" y="1700784"/>
+            <a:ext cx="4343400" cy="182880"/>
+          </a:xfrm>
+          <a:prstGeom prst="rect">
+            <a:avLst/>
+          </a:prstGeom>
+          <a:noFill/>
+        </p:spPr>
+        <p:txBody>
+          <a:bodyPr wrap="none" lIns="0" rIns="0" tIns="0" bIns="0" anchor="ctr">
+            <a:spAutoFit/>
+          </a:bodyPr>
+          <a:lstStyle/>
+          <a:p>
+            <a:pPr algn="l">
+              <a:spcBef>
+                <a:spcPts val="0"/>
+              </a:spcBef>
+              <a:spcAft>
+                <a:spcPts val="0"/>
+              </a:spcAft>
+            </a:pPr>
+            <a:r>
+              <a:rPr sz="819" b="0">
+                <a:solidFill>
+                  <a:srgbClr val="A9B0B2"/>
+                </a:solidFill>
+                <a:latin typeface="Arial"/>
+              </a:rPr>
+              <a:t>Selected European trading-loss cases</a:t>
+            </a:r>
+          </a:p>
+        </p:txBody>
+      </p:sp>
+      <p:sp>
+        <p:nvSpPr>
+          <p:cNvPr id="17" name="Rectangle 16"/>
           <p:cNvSpPr/>
           <p:nvPr/>
         </p:nvSpPr>
         <p:spPr>
           <a:xfrm>
-            <a:off x="7900416" y="3529584"/>
-            <a:ext cx="50292" cy="557784"/>
-          </a:xfrm>
-          <a:prstGeom prst="roundRect">
+            <a:off x="7306056" y="1965960"/>
+            <a:ext cx="4325112" cy="7315"/>
+          </a:xfrm>
+          <a:prstGeom prst="rect">
             <a:avLst/>
           </a:prstGeom>
           <a:solidFill>
-            <a:srgbClr val="B82631"/>
+            <a:srgbClr val="30373B"/>
           </a:solidFill>
           <a:ln>
             <a:noFill/>
@@ -3724,14 +3726,14 @@
       </p:sp>
       <p:sp>
         <p:nvSpPr>
-          <p:cNvPr id="17" name="TextBox 16"/>
+          <p:cNvPr id="18" name="TextBox 17"/>
           <p:cNvSpPr txBox="1"/>
           <p:nvPr/>
         </p:nvSpPr>
         <p:spPr>
           <a:xfrm>
-            <a:off x="8065008" y="3438144"/>
-            <a:ext cx="2697480" cy="246888"/>
+            <a:off x="7324344" y="2157984"/>
+            <a:ext cx="2487168" cy="210312"/>
           </a:xfrm>
           <a:prstGeom prst="rect">
             <a:avLst/>
@@ -3753,27 +3755,27 @@
               </a:spcAft>
             </a:pPr>
             <a:r>
-              <a:rPr sz="1250" b="1">
+              <a:rPr sz="1000" b="1">
                 <a:solidFill>
-                  <a:srgbClr val="173044"/>
+                  <a:srgbClr val="F7F8F6"/>
                 </a:solidFill>
                 <a:latin typeface="Arial"/>
               </a:rPr>
-              <a:t>KERVIEL</a:t>
-            </a:r>
-          </a:p>
-        </p:txBody>
-      </p:sp>
-      <p:sp>
-        <p:nvSpPr>
-          <p:cNvPr id="18" name="TextBox 17"/>
+              <a:t>BARINGS</a:t>
+            </a:r>
+          </a:p>
+        </p:txBody>
+      </p:sp>
+      <p:sp>
+        <p:nvSpPr>
+          <p:cNvPr id="19" name="TextBox 18"/>
           <p:cNvSpPr txBox="1"/>
           <p:nvPr/>
         </p:nvSpPr>
         <p:spPr>
           <a:xfrm>
-            <a:off x="10762488" y="3438144"/>
-            <a:ext cx="548640" cy="246888"/>
+            <a:off x="11036808" y="2157984"/>
+            <a:ext cx="502920" cy="210312"/>
           </a:xfrm>
           <a:prstGeom prst="rect">
             <a:avLst/>
@@ -3795,27 +3797,27 @@
               </a:spcAft>
             </a:pPr>
             <a:r>
-              <a:rPr sz="950" b="1">
+              <a:rPr sz="900" b="1">
                 <a:solidFill>
-                  <a:srgbClr val="B82631"/>
+                  <a:srgbClr val="D6A600"/>
                 </a:solidFill>
                 <a:latin typeface="Arial"/>
               </a:rPr>
-              <a:t>2008</a:t>
-            </a:r>
-          </a:p>
-        </p:txBody>
-      </p:sp>
-      <p:sp>
-        <p:nvSpPr>
-          <p:cNvPr id="19" name="TextBox 18"/>
+              <a:t>1995</a:t>
+            </a:r>
+          </a:p>
+        </p:txBody>
+      </p:sp>
+      <p:sp>
+        <p:nvSpPr>
+          <p:cNvPr id="20" name="TextBox 19"/>
           <p:cNvSpPr txBox="1"/>
           <p:nvPr/>
         </p:nvSpPr>
         <p:spPr>
           <a:xfrm>
-            <a:off x="8065008" y="3749040"/>
-            <a:ext cx="2103120" cy="384048"/>
+            <a:off x="7324344" y="2414015"/>
+            <a:ext cx="2359152" cy="347472"/>
           </a:xfrm>
           <a:prstGeom prst="rect">
             <a:avLst/>
@@ -3837,80 +3839,36 @@
               </a:spcAft>
             </a:pPr>
             <a:r>
-              <a:rPr sz="1900" b="1">
+              <a:rPr sz="1800" b="1">
                 <a:solidFill>
-                  <a:srgbClr val="B82631"/>
+                  <a:srgbClr val="D6A600"/>
                 </a:solidFill>
                 <a:latin typeface="Arial"/>
               </a:rPr>
-              <a:t>EUR -4.9bn</a:t>
-            </a:r>
-          </a:p>
-        </p:txBody>
-      </p:sp>
-      <p:sp>
-        <p:nvSpPr>
-          <p:cNvPr id="20" name="TextBox 19"/>
-          <p:cNvSpPr txBox="1"/>
+              <a:t>USD -1.4bn</a:t>
+            </a:r>
+          </a:p>
+        </p:txBody>
+      </p:sp>
+      <p:sp>
+        <p:nvSpPr>
+          <p:cNvPr id="21" name="Rectangle 20"/>
+          <p:cNvSpPr/>
           <p:nvPr/>
         </p:nvSpPr>
         <p:spPr>
           <a:xfrm>
-            <a:off x="9747504" y="3822191"/>
-            <a:ext cx="1554480" cy="228600"/>
+            <a:off x="7306056" y="2907792"/>
+            <a:ext cx="4325112" cy="7315"/>
           </a:xfrm>
           <a:prstGeom prst="rect">
             <a:avLst/>
           </a:prstGeom>
-          <a:noFill/>
-        </p:spPr>
-        <p:txBody>
-          <a:bodyPr wrap="none" lIns="0" rIns="0" tIns="0" bIns="0" anchor="ctr">
-            <a:spAutoFit/>
-          </a:bodyPr>
-          <a:lstStyle/>
-          <a:p>
-            <a:pPr algn="r">
-              <a:spcBef>
-                <a:spcPts val="0"/>
-              </a:spcBef>
-              <a:spcAft>
-                <a:spcPts val="0"/>
-              </a:spcAft>
-            </a:pPr>
-            <a:r>
-              <a:rPr sz="900" b="0">
-                <a:solidFill>
-                  <a:srgbClr val="647684"/>
-                </a:solidFill>
-                <a:latin typeface="Arial"/>
-              </a:rPr>
-              <a:t>Société Générale</a:t>
-            </a:r>
-          </a:p>
-        </p:txBody>
-      </p:sp>
-      <p:sp>
-        <p:nvSpPr>
-          <p:cNvPr id="21" name="Rounded Rectangle 20"/>
-          <p:cNvSpPr/>
-          <p:nvPr/>
-        </p:nvSpPr>
-        <p:spPr>
-          <a:xfrm>
-            <a:off x="7754112" y="4407408"/>
-            <a:ext cx="3767328" cy="932688"/>
-          </a:xfrm>
-          <a:prstGeom prst="roundRect">
-            <a:avLst/>
-          </a:prstGeom>
           <a:solidFill>
-            <a:srgbClr val="FFFFFF"/>
+            <a:srgbClr val="30373B"/>
           </a:solidFill>
-          <a:ln w="10160">
-            <a:solidFill>
-              <a:srgbClr val="E1E8EE"/>
-            </a:solidFill>
+          <a:ln>
+            <a:noFill/>
           </a:ln>
         </p:spPr>
         <p:style>
@@ -3937,20 +3895,188 @@
       </p:sp>
       <p:sp>
         <p:nvSpPr>
-          <p:cNvPr id="22" name="Rounded Rectangle 21"/>
+          <p:cNvPr id="22" name="TextBox 21"/>
+          <p:cNvSpPr txBox="1"/>
+          <p:nvPr/>
+        </p:nvSpPr>
+        <p:spPr>
+          <a:xfrm>
+            <a:off x="7324344" y="3090672"/>
+            <a:ext cx="2487168" cy="210312"/>
+          </a:xfrm>
+          <a:prstGeom prst="rect">
+            <a:avLst/>
+          </a:prstGeom>
+          <a:noFill/>
+        </p:spPr>
+        <p:txBody>
+          <a:bodyPr wrap="none" lIns="0" rIns="0" tIns="0" bIns="0" anchor="ctr">
+            <a:spAutoFit/>
+          </a:bodyPr>
+          <a:lstStyle/>
+          <a:p>
+            <a:pPr algn="l">
+              <a:spcBef>
+                <a:spcPts val="0"/>
+              </a:spcBef>
+              <a:spcAft>
+                <a:spcPts val="0"/>
+              </a:spcAft>
+            </a:pPr>
+            <a:r>
+              <a:rPr sz="1000" b="1">
+                <a:solidFill>
+                  <a:srgbClr val="F7F8F6"/>
+                </a:solidFill>
+                <a:latin typeface="Arial"/>
+              </a:rPr>
+              <a:t>KERVIEL</a:t>
+            </a:r>
+          </a:p>
+        </p:txBody>
+      </p:sp>
+      <p:sp>
+        <p:nvSpPr>
+          <p:cNvPr id="23" name="TextBox 22"/>
+          <p:cNvSpPr txBox="1"/>
+          <p:nvPr/>
+        </p:nvSpPr>
+        <p:spPr>
+          <a:xfrm>
+            <a:off x="11036808" y="3090672"/>
+            <a:ext cx="502920" cy="210312"/>
+          </a:xfrm>
+          <a:prstGeom prst="rect">
+            <a:avLst/>
+          </a:prstGeom>
+          <a:noFill/>
+        </p:spPr>
+        <p:txBody>
+          <a:bodyPr wrap="none" lIns="0" rIns="0" tIns="0" bIns="0" anchor="ctr">
+            <a:spAutoFit/>
+          </a:bodyPr>
+          <a:lstStyle/>
+          <a:p>
+            <a:pPr algn="r">
+              <a:spcBef>
+                <a:spcPts val="0"/>
+              </a:spcBef>
+              <a:spcAft>
+                <a:spcPts val="0"/>
+              </a:spcAft>
+            </a:pPr>
+            <a:r>
+              <a:rPr sz="900" b="1">
+                <a:solidFill>
+                  <a:srgbClr val="C82036"/>
+                </a:solidFill>
+                <a:latin typeface="Arial"/>
+              </a:rPr>
+              <a:t>2008</a:t>
+            </a:r>
+          </a:p>
+        </p:txBody>
+      </p:sp>
+      <p:sp>
+        <p:nvSpPr>
+          <p:cNvPr id="24" name="TextBox 23"/>
+          <p:cNvSpPr txBox="1"/>
+          <p:nvPr/>
+        </p:nvSpPr>
+        <p:spPr>
+          <a:xfrm>
+            <a:off x="7324344" y="3346704"/>
+            <a:ext cx="2359152" cy="347472"/>
+          </a:xfrm>
+          <a:prstGeom prst="rect">
+            <a:avLst/>
+          </a:prstGeom>
+          <a:noFill/>
+        </p:spPr>
+        <p:txBody>
+          <a:bodyPr wrap="none" lIns="0" rIns="0" tIns="0" bIns="0" anchor="ctr">
+            <a:spAutoFit/>
+          </a:bodyPr>
+          <a:lstStyle/>
+          <a:p>
+            <a:pPr algn="l">
+              <a:spcBef>
+                <a:spcPts val="0"/>
+              </a:spcBef>
+              <a:spcAft>
+                <a:spcPts val="0"/>
+              </a:spcAft>
+            </a:pPr>
+            <a:r>
+              <a:rPr sz="1800" b="1">
+                <a:solidFill>
+                  <a:srgbClr val="C82036"/>
+                </a:solidFill>
+                <a:latin typeface="Arial"/>
+              </a:rPr>
+              <a:t>EUR -4.9bn</a:t>
+            </a:r>
+          </a:p>
+        </p:txBody>
+      </p:sp>
+      <p:sp>
+        <p:nvSpPr>
+          <p:cNvPr id="25" name="TextBox 24"/>
+          <p:cNvSpPr txBox="1"/>
+          <p:nvPr/>
+        </p:nvSpPr>
+        <p:spPr>
+          <a:xfrm>
+            <a:off x="9720072" y="3401568"/>
+            <a:ext cx="1883663" cy="219456"/>
+          </a:xfrm>
+          <a:prstGeom prst="rect">
+            <a:avLst/>
+          </a:prstGeom>
+          <a:noFill/>
+        </p:spPr>
+        <p:txBody>
+          <a:bodyPr wrap="none" lIns="0" rIns="0" tIns="0" bIns="0" anchor="ctr">
+            <a:spAutoFit/>
+          </a:bodyPr>
+          <a:lstStyle/>
+          <a:p>
+            <a:pPr algn="r">
+              <a:spcBef>
+                <a:spcPts val="0"/>
+              </a:spcBef>
+              <a:spcAft>
+                <a:spcPts val="0"/>
+              </a:spcAft>
+            </a:pPr>
+            <a:r>
+              <a:rPr sz="850" b="0">
+                <a:solidFill>
+                  <a:srgbClr val="A9B0B2"/>
+                </a:solidFill>
+                <a:latin typeface="Arial"/>
+              </a:rPr>
+              <a:t>Société Générale</a:t>
+            </a:r>
+          </a:p>
+        </p:txBody>
+      </p:sp>
+      <p:sp>
+        <p:nvSpPr>
+          <p:cNvPr id="26" name="Rectangle 25"/>
           <p:cNvSpPr/>
           <p:nvPr/>
         </p:nvSpPr>
         <p:spPr>
           <a:xfrm>
-            <a:off x="7900416" y="4590288"/>
-            <a:ext cx="50292" cy="557784"/>
-          </a:xfrm>
-          <a:prstGeom prst="roundRect">
+            <a:off x="7306056" y="3840480"/>
+            <a:ext cx="4325112" cy="7315"/>
+          </a:xfrm>
+          <a:prstGeom prst="rect">
             <a:avLst/>
           </a:prstGeom>
           <a:solidFill>
-            <a:srgbClr val="C8272C"/>
+            <a:srgbClr val="30373B"/>
           </a:solidFill>
           <a:ln>
             <a:noFill/>
@@ -3980,14 +4106,14 @@
       </p:sp>
       <p:sp>
         <p:nvSpPr>
-          <p:cNvPr id="23" name="TextBox 22"/>
+          <p:cNvPr id="27" name="TextBox 26"/>
           <p:cNvSpPr txBox="1"/>
           <p:nvPr/>
         </p:nvSpPr>
         <p:spPr>
           <a:xfrm>
-            <a:off x="8065008" y="4498848"/>
-            <a:ext cx="2697480" cy="246888"/>
+            <a:off x="7324344" y="4023360"/>
+            <a:ext cx="2487168" cy="210312"/>
           </a:xfrm>
           <a:prstGeom prst="rect">
             <a:avLst/>
@@ -4009,9 +4135,9 @@
               </a:spcAft>
             </a:pPr>
             <a:r>
-              <a:rPr sz="1250" b="1">
+              <a:rPr sz="1000" b="1">
                 <a:solidFill>
-                  <a:srgbClr val="173044"/>
+                  <a:srgbClr val="F7F8F6"/>
                 </a:solidFill>
                 <a:latin typeface="Arial"/>
               </a:rPr>
@@ -4022,14 +4148,14 @@
       </p:sp>
       <p:sp>
         <p:nvSpPr>
-          <p:cNvPr id="24" name="TextBox 23"/>
+          <p:cNvPr id="28" name="TextBox 27"/>
           <p:cNvSpPr txBox="1"/>
           <p:nvPr/>
         </p:nvSpPr>
         <p:spPr>
           <a:xfrm>
-            <a:off x="10762488" y="4498848"/>
-            <a:ext cx="548640" cy="246888"/>
+            <a:off x="11036808" y="4023360"/>
+            <a:ext cx="502920" cy="210312"/>
           </a:xfrm>
           <a:prstGeom prst="rect">
             <a:avLst/>
@@ -4051,9 +4177,9 @@
               </a:spcAft>
             </a:pPr>
             <a:r>
-              <a:rPr sz="950" b="1">
+              <a:rPr sz="900" b="1">
                 <a:solidFill>
-                  <a:srgbClr val="C8272C"/>
+                  <a:srgbClr val="C82036"/>
                 </a:solidFill>
                 <a:latin typeface="Arial"/>
               </a:rPr>
@@ -4064,14 +4190,14 @@
       </p:sp>
       <p:sp>
         <p:nvSpPr>
-          <p:cNvPr id="25" name="TextBox 24"/>
+          <p:cNvPr id="29" name="TextBox 28"/>
           <p:cNvSpPr txBox="1"/>
           <p:nvPr/>
         </p:nvSpPr>
         <p:spPr>
           <a:xfrm>
-            <a:off x="8065008" y="4809744"/>
-            <a:ext cx="2103120" cy="384048"/>
+            <a:off x="7324344" y="4279392"/>
+            <a:ext cx="2359152" cy="347472"/>
           </a:xfrm>
           <a:prstGeom prst="rect">
             <a:avLst/>
@@ -4093,9 +4219,9 @@
               </a:spcAft>
             </a:pPr>
             <a:r>
-              <a:rPr sz="1900" b="1">
+              <a:rPr sz="1800" b="1">
                 <a:solidFill>
-                  <a:srgbClr val="C8272C"/>
+                  <a:srgbClr val="C82036"/>
                 </a:solidFill>
                 <a:latin typeface="Arial"/>
               </a:rPr>
@@ -4106,14 +4232,14 @@
       </p:sp>
       <p:sp>
         <p:nvSpPr>
-          <p:cNvPr id="26" name="TextBox 25"/>
+          <p:cNvPr id="30" name="TextBox 29"/>
           <p:cNvSpPr txBox="1"/>
           <p:nvPr/>
         </p:nvSpPr>
         <p:spPr>
           <a:xfrm>
-            <a:off x="9747504" y="4882896"/>
-            <a:ext cx="1554480" cy="228600"/>
+            <a:off x="9720072" y="4334256"/>
+            <a:ext cx="1883663" cy="219456"/>
           </a:xfrm>
           <a:prstGeom prst="rect">
             <a:avLst/>
@@ -4135,9 +4261,9 @@
               </a:spcAft>
             </a:pPr>
             <a:r>
-              <a:rPr sz="900" b="0">
+              <a:rPr sz="850" b="0">
                 <a:solidFill>
-                  <a:srgbClr val="647684"/>
+                  <a:srgbClr val="A9B0B2"/>
                 </a:solidFill>
                 <a:latin typeface="Arial"/>
               </a:rPr>
@@ -4148,20 +4274,20 @@
       </p:sp>
       <p:sp>
         <p:nvSpPr>
-          <p:cNvPr id="27" name="Rounded Rectangle 26"/>
+          <p:cNvPr id="31" name="Rectangle 30"/>
           <p:cNvSpPr/>
           <p:nvPr/>
         </p:nvSpPr>
         <p:spPr>
           <a:xfrm>
-            <a:off x="7754112" y="5486400"/>
-            <a:ext cx="3767328" cy="749808"/>
-          </a:xfrm>
-          <a:prstGeom prst="roundRect">
+            <a:off x="7306056" y="4773168"/>
+            <a:ext cx="4325112" cy="7315"/>
+          </a:xfrm>
+          <a:prstGeom prst="rect">
             <a:avLst/>
           </a:prstGeom>
           <a:solidFill>
-            <a:srgbClr val="173044"/>
+            <a:srgbClr val="30373B"/>
           </a:solidFill>
           <a:ln>
             <a:noFill/>
@@ -4191,14 +4317,14 @@
       </p:sp>
       <p:sp>
         <p:nvSpPr>
-          <p:cNvPr id="28" name="TextBox 27"/>
+          <p:cNvPr id="32" name="TextBox 31"/>
           <p:cNvSpPr txBox="1"/>
           <p:nvPr/>
         </p:nvSpPr>
         <p:spPr>
           <a:xfrm>
-            <a:off x="7955279" y="5586984"/>
-            <a:ext cx="3337560" cy="173736"/>
+            <a:off x="7324344" y="4965192"/>
+            <a:ext cx="4251960" cy="182880"/>
           </a:xfrm>
           <a:prstGeom prst="rect">
             <a:avLst/>
@@ -4220,27 +4346,27 @@
               </a:spcAft>
             </a:pPr>
             <a:r>
-              <a:rPr sz="850" b="1">
+              <a:rPr sz="819" b="1">
                 <a:solidFill>
-                  <a:srgbClr val="75D8CF"/>
+                  <a:srgbClr val="D6A600"/>
                 </a:solidFill>
                 <a:latin typeface="Arial"/>
               </a:rPr>
-              <a:t>LOCATION MATTERS</a:t>
-            </a:r>
-          </a:p>
-        </p:txBody>
-      </p:sp>
-      <p:sp>
-        <p:nvSpPr>
-          <p:cNvPr id="29" name="TextBox 28"/>
+              <a:t>LOCATION NOTE</a:t>
+            </a:r>
+          </a:p>
+        </p:txBody>
+      </p:sp>
+      <p:sp>
+        <p:nvSpPr>
+          <p:cNvPr id="33" name="TextBox 32"/>
           <p:cNvSpPr txBox="1"/>
           <p:nvPr/>
         </p:nvSpPr>
         <p:spPr>
           <a:xfrm>
-            <a:off x="7955279" y="5797296"/>
-            <a:ext cx="3337560" cy="356616"/>
+            <a:off x="7324344" y="5212080"/>
+            <a:ext cx="4251960" cy="219456"/>
           </a:xfrm>
           <a:prstGeom prst="rect">
             <a:avLst/>
@@ -4262,13 +4388,224 @@
               </a:spcAft>
             </a:pPr>
             <a:r>
-              <a:rPr sz="1050" b="0">
+              <a:rPr sz="1000" b="1">
                 <a:solidFill>
-                  <a:srgbClr val="FFFFFF"/>
+                  <a:srgbClr val="F7F8F6"/>
                 </a:solidFill>
                 <a:latin typeface="Arial"/>
               </a:rPr>
-              <a:t>Adoboli traded from London; UBS headquarters are in Zurich.</a:t>
+              <a:t>Adoboli's trading desk: London</a:t>
+            </a:r>
+          </a:p>
+        </p:txBody>
+      </p:sp>
+      <p:sp>
+        <p:nvSpPr>
+          <p:cNvPr id="34" name="TextBox 33"/>
+          <p:cNvSpPr txBox="1"/>
+          <p:nvPr/>
+        </p:nvSpPr>
+        <p:spPr>
+          <a:xfrm>
+            <a:off x="7324344" y="5477256"/>
+            <a:ext cx="4251960" cy="210312"/>
+          </a:xfrm>
+          <a:prstGeom prst="rect">
+            <a:avLst/>
+          </a:prstGeom>
+          <a:noFill/>
+        </p:spPr>
+        <p:txBody>
+          <a:bodyPr wrap="none" lIns="0" rIns="0" tIns="0" bIns="0" anchor="ctr">
+            <a:spAutoFit/>
+          </a:bodyPr>
+          <a:lstStyle/>
+          <a:p>
+            <a:pPr algn="l">
+              <a:spcBef>
+                <a:spcPts val="0"/>
+              </a:spcBef>
+              <a:spcAft>
+                <a:spcPts val="0"/>
+              </a:spcAft>
+            </a:pPr>
+            <a:r>
+              <a:rPr sz="900" b="0">
+                <a:solidFill>
+                  <a:srgbClr val="A9B0B2"/>
+                </a:solidFill>
+                <a:latin typeface="Arial"/>
+              </a:rPr>
+              <a:t>UBS Group headquarters: Zurich</a:t>
+            </a:r>
+          </a:p>
+        </p:txBody>
+      </p:sp>
+      <p:sp>
+        <p:nvSpPr>
+          <p:cNvPr id="35" name="Rectangle 34"/>
+          <p:cNvSpPr/>
+          <p:nvPr/>
+        </p:nvSpPr>
+        <p:spPr>
+          <a:xfrm>
+            <a:off x="384048" y="6291072"/>
+            <a:ext cx="11439144" cy="10972"/>
+          </a:xfrm>
+          <a:prstGeom prst="rect">
+            <a:avLst/>
+          </a:prstGeom>
+          <a:solidFill>
+            <a:srgbClr val="C9CDCA"/>
+          </a:solidFill>
+          <a:ln>
+            <a:noFill/>
+          </a:ln>
+        </p:spPr>
+        <p:style>
+          <a:lnRef idx="1">
+            <a:schemeClr val="accent1"/>
+          </a:lnRef>
+          <a:fillRef idx="3">
+            <a:schemeClr val="accent1"/>
+          </a:fillRef>
+          <a:effectRef idx="2">
+            <a:schemeClr val="accent1"/>
+          </a:effectRef>
+          <a:fontRef idx="minor">
+            <a:schemeClr val="lt1"/>
+          </a:fontRef>
+        </p:style>
+        <p:txBody>
+          <a:bodyPr rtlCol="0" anchor="ctr"/>
+          <a:lstStyle/>
+          <a:p>
+            <a:pPr algn="ctr"/>
+          </a:p>
+        </p:txBody>
+      </p:sp>
+      <p:sp>
+        <p:nvSpPr>
+          <p:cNvPr id="36" name="TextBox 35"/>
+          <p:cNvSpPr txBox="1"/>
+          <p:nvPr/>
+        </p:nvSpPr>
+        <p:spPr>
+          <a:xfrm>
+            <a:off x="402336" y="6373368"/>
+            <a:ext cx="1444752" cy="164592"/>
+          </a:xfrm>
+          <a:prstGeom prst="rect">
+            <a:avLst/>
+          </a:prstGeom>
+          <a:noFill/>
+        </p:spPr>
+        <p:txBody>
+          <a:bodyPr wrap="none" lIns="0" rIns="0" tIns="0" bIns="0" anchor="ctr">
+            <a:spAutoFit/>
+          </a:bodyPr>
+          <a:lstStyle/>
+          <a:p>
+            <a:pPr algn="l">
+              <a:spcBef>
+                <a:spcPts val="0"/>
+              </a:spcBef>
+              <a:spcAft>
+                <a:spcPts val="0"/>
+              </a:spcAft>
+            </a:pPr>
+            <a:r>
+              <a:rPr sz="760" b="1">
+                <a:solidFill>
+                  <a:srgbClr val="C82036"/>
+                </a:solidFill>
+                <a:latin typeface="Arial"/>
+              </a:rPr>
+              <a:t>EXECUTIVE SUMMARY</a:t>
+            </a:r>
+          </a:p>
+        </p:txBody>
+      </p:sp>
+      <p:sp>
+        <p:nvSpPr>
+          <p:cNvPr id="37" name="TextBox 36"/>
+          <p:cNvSpPr txBox="1"/>
+          <p:nvPr/>
+        </p:nvSpPr>
+        <p:spPr>
+          <a:xfrm>
+            <a:off x="1847088" y="6355080"/>
+            <a:ext cx="9829800" cy="210312"/>
+          </a:xfrm>
+          <a:prstGeom prst="rect">
+            <a:avLst/>
+          </a:prstGeom>
+          <a:noFill/>
+        </p:spPr>
+        <p:txBody>
+          <a:bodyPr wrap="none" lIns="0" rIns="0" tIns="0" bIns="0" anchor="ctr">
+            <a:spAutoFit/>
+          </a:bodyPr>
+          <a:lstStyle/>
+          <a:p>
+            <a:pPr algn="l">
+              <a:spcBef>
+                <a:spcPts val="0"/>
+              </a:spcBef>
+              <a:spcAft>
+                <a:spcPts val="0"/>
+              </a:spcAft>
+            </a:pPr>
+            <a:r>
+              <a:rPr sz="1030" b="1">
+                <a:solidFill>
+                  <a:srgbClr val="18232B"/>
+                </a:solidFill>
+                <a:latin typeface="Arial"/>
+              </a:rPr>
+              <a:t>The UBS case shows how control failures can escalate into material losses and liquidity pressure.</a:t>
+            </a:r>
+          </a:p>
+        </p:txBody>
+      </p:sp>
+      <p:sp>
+        <p:nvSpPr>
+          <p:cNvPr id="38" name="TextBox 37"/>
+          <p:cNvSpPr txBox="1"/>
+          <p:nvPr/>
+        </p:nvSpPr>
+        <p:spPr>
+          <a:xfrm>
+            <a:off x="10899648" y="6638544"/>
+            <a:ext cx="868680" cy="109728"/>
+          </a:xfrm>
+          <a:prstGeom prst="rect">
+            <a:avLst/>
+          </a:prstGeom>
+          <a:noFill/>
+        </p:spPr>
+        <p:txBody>
+          <a:bodyPr wrap="none" lIns="0" rIns="0" tIns="0" bIns="0" anchor="ctr">
+            <a:spAutoFit/>
+          </a:bodyPr>
+          <a:lstStyle/>
+          <a:p>
+            <a:pPr algn="r">
+              <a:spcBef>
+                <a:spcPts val="0"/>
+              </a:spcBef>
+              <a:spcAft>
+                <a:spcPts val="0"/>
+              </a:spcAft>
+            </a:pPr>
+            <a:r>
+              <a:rPr sz="640" b="1">
+                <a:solidFill>
+                  <a:srgbClr val="737B80"/>
+                </a:solidFill>
+                <a:latin typeface="Arial"/>
+              </a:rPr>
+              <a:t>UBS  ×  SKEMA</a:t>
             </a:r>
           </a:p>
         </p:txBody>

</xml_diff>

<commit_message>
Simplify event map slide to map and summary
Co-authored-by: arena-agent <297053741+arena-agent@users.noreply.github.com>
</commit_message>
<xml_diff>
--- a/documents/ubs-event-map-slide.pptx
+++ b/documents/ubs-event-map-slide.pptx
@@ -3157,7 +3157,7 @@
                 </a:solidFill>
                 <a:latin typeface="Arial"/>
               </a:rPr>
-              <a:t>UBS INVESTMENT BANK  |  2011</a:t>
+              <a:t>MAJOR EUROPEAN TRADING LOSS EVENTS</a:t>
             </a:r>
           </a:p>
         </p:txBody>
@@ -3199,7 +3199,7 @@
                 </a:solidFill>
                 <a:latin typeface="Arial"/>
               </a:rPr>
-              <a:t>EUROPEAN TRADING-LOSS BENCHMARKS</a:t>
+              <a:t>SELECTED BENCHMARKS RELEVANT TO UBS 2011</a:t>
             </a:r>
           </a:p>
         </p:txBody>
@@ -3313,181 +3313,9 @@
           </a:p>
         </p:txBody>
       </p:sp>
-      <p:sp>
-        <p:nvSpPr>
-          <p:cNvPr id="8" name="TextBox 7"/>
-          <p:cNvSpPr txBox="1"/>
-          <p:nvPr/>
-        </p:nvSpPr>
-        <p:spPr>
-          <a:xfrm>
-            <a:off x="393192" y="960120"/>
-            <a:ext cx="5577840" cy="182880"/>
-          </a:xfrm>
-          <a:prstGeom prst="rect">
-            <a:avLst/>
-          </a:prstGeom>
-          <a:noFill/>
-        </p:spPr>
-        <p:txBody>
-          <a:bodyPr wrap="none" lIns="0" rIns="0" tIns="0" bIns="0" anchor="ctr">
-            <a:spAutoFit/>
-          </a:bodyPr>
-          <a:lstStyle/>
-          <a:p>
-            <a:pPr algn="l">
-              <a:spcBef>
-                <a:spcPts val="0"/>
-              </a:spcBef>
-              <a:spcAft>
-                <a:spcPts val="0"/>
-              </a:spcAft>
-            </a:pPr>
-            <a:r>
-              <a:rPr sz="770" b="1">
-                <a:solidFill>
-                  <a:srgbClr val="737B80"/>
-                </a:solidFill>
-                <a:latin typeface="Arial"/>
-              </a:rPr>
-              <a:t>EUROPEAN LOSS EVENTS  /  MAP &amp; BENCHMARKS</a:t>
-            </a:r>
-          </a:p>
-        </p:txBody>
-      </p:sp>
-      <p:sp>
-        <p:nvSpPr>
-          <p:cNvPr id="9" name="TextBox 8"/>
-          <p:cNvSpPr txBox="1"/>
-          <p:nvPr/>
-        </p:nvSpPr>
-        <p:spPr>
-          <a:xfrm>
-            <a:off x="6949440" y="960120"/>
-            <a:ext cx="4800600" cy="182880"/>
-          </a:xfrm>
-          <a:prstGeom prst="rect">
-            <a:avLst/>
-          </a:prstGeom>
-          <a:noFill/>
-        </p:spPr>
-        <p:txBody>
-          <a:bodyPr wrap="none" lIns="0" rIns="0" tIns="0" bIns="0" anchor="ctr">
-            <a:spAutoFit/>
-          </a:bodyPr>
-          <a:lstStyle/>
-          <a:p>
-            <a:pPr algn="r">
-              <a:spcBef>
-                <a:spcPts val="0"/>
-              </a:spcBef>
-              <a:spcAft>
-                <a:spcPts val="0"/>
-              </a:spcAft>
-            </a:pPr>
-            <a:r>
-              <a:rPr sz="770" b="1">
-                <a:solidFill>
-                  <a:srgbClr val="737B80"/>
-                </a:solidFill>
-                <a:latin typeface="Arial"/>
-              </a:rPr>
-              <a:t>HISTORICAL CASES  ·  LOSS FIGURES AS LABELLED</a:t>
-            </a:r>
-          </a:p>
-        </p:txBody>
-      </p:sp>
-      <p:sp>
-        <p:nvSpPr>
-          <p:cNvPr id="10" name="Rectangle 9"/>
-          <p:cNvSpPr/>
-          <p:nvPr/>
-        </p:nvSpPr>
-        <p:spPr>
-          <a:xfrm>
-            <a:off x="384048" y="1197864"/>
-            <a:ext cx="6583680" cy="4965192"/>
-          </a:xfrm>
-          <a:prstGeom prst="rect">
-            <a:avLst/>
-          </a:prstGeom>
-          <a:solidFill>
-            <a:srgbClr val="101315"/>
-          </a:solidFill>
-          <a:ln w="10160">
-            <a:solidFill>
-              <a:srgbClr val="30373B"/>
-            </a:solidFill>
-          </a:ln>
-        </p:spPr>
-        <p:style>
-          <a:lnRef idx="1">
-            <a:schemeClr val="accent1"/>
-          </a:lnRef>
-          <a:fillRef idx="3">
-            <a:schemeClr val="accent1"/>
-          </a:fillRef>
-          <a:effectRef idx="2">
-            <a:schemeClr val="accent1"/>
-          </a:effectRef>
-          <a:fontRef idx="minor">
-            <a:schemeClr val="lt1"/>
-          </a:fontRef>
-        </p:style>
-        <p:txBody>
-          <a:bodyPr rtlCol="0" anchor="ctr"/>
-          <a:lstStyle/>
-          <a:p>
-            <a:pPr algn="ctr"/>
-          </a:p>
-        </p:txBody>
-      </p:sp>
-      <p:sp>
-        <p:nvSpPr>
-          <p:cNvPr id="11" name="Rectangle 10"/>
-          <p:cNvSpPr/>
-          <p:nvPr/>
-        </p:nvSpPr>
-        <p:spPr>
-          <a:xfrm>
-            <a:off x="384048" y="1197864"/>
-            <a:ext cx="6583680" cy="41148"/>
-          </a:xfrm>
-          <a:prstGeom prst="rect">
-            <a:avLst/>
-          </a:prstGeom>
-          <a:solidFill>
-            <a:srgbClr val="00A985"/>
-          </a:solidFill>
-          <a:ln>
-            <a:noFill/>
-          </a:ln>
-        </p:spPr>
-        <p:style>
-          <a:lnRef idx="1">
-            <a:schemeClr val="accent1"/>
-          </a:lnRef>
-          <a:fillRef idx="3">
-            <a:schemeClr val="accent1"/>
-          </a:fillRef>
-          <a:effectRef idx="2">
-            <a:schemeClr val="accent1"/>
-          </a:effectRef>
-          <a:fontRef idx="minor">
-            <a:schemeClr val="lt1"/>
-          </a:fontRef>
-        </p:style>
-        <p:txBody>
-          <a:bodyPr rtlCol="0" anchor="ctr"/>
-          <a:lstStyle/>
-          <a:p>
-            <a:pPr algn="ctr"/>
-          </a:p>
-        </p:txBody>
-      </p:sp>
       <p:pic>
         <p:nvPicPr>
-          <p:cNvPr id="12" name="Picture 11" descr="ubs-event-map-approved.png"/>
+          <p:cNvPr id="8" name="Picture 7" descr="ubs-event-map-approved.png"/>
           <p:cNvPicPr>
             <a:picLocks noChangeAspect="1"/>
           </p:cNvPicPr>
@@ -3501,8 +3329,8 @@
         </p:blipFill>
         <p:spPr>
           <a:xfrm>
-            <a:off x="448056" y="1271016"/>
-            <a:ext cx="6393425" cy="4800600"/>
+            <a:off x="2613105" y="987552"/>
+            <a:ext cx="6965789" cy="5230368"/>
           </a:xfrm>
           <a:prstGeom prst="rect">
             <a:avLst/>
@@ -3511,945 +3339,13 @@
       </p:pic>
       <p:sp>
         <p:nvSpPr>
-          <p:cNvPr id="13" name="Rectangle 12"/>
+          <p:cNvPr id="9" name="Rectangle 8"/>
           <p:cNvSpPr/>
           <p:nvPr/>
         </p:nvSpPr>
         <p:spPr>
           <a:xfrm>
-            <a:off x="7114032" y="1197864"/>
-            <a:ext cx="4709160" cy="4965192"/>
-          </a:xfrm>
-          <a:prstGeom prst="rect">
-            <a:avLst/>
-          </a:prstGeom>
-          <a:solidFill>
-            <a:srgbClr val="101315"/>
-          </a:solidFill>
-          <a:ln w="10160">
-            <a:solidFill>
-              <a:srgbClr val="30373B"/>
-            </a:solidFill>
-          </a:ln>
-        </p:spPr>
-        <p:style>
-          <a:lnRef idx="1">
-            <a:schemeClr val="accent1"/>
-          </a:lnRef>
-          <a:fillRef idx="3">
-            <a:schemeClr val="accent1"/>
-          </a:fillRef>
-          <a:effectRef idx="2">
-            <a:schemeClr val="accent1"/>
-          </a:effectRef>
-          <a:fontRef idx="minor">
-            <a:schemeClr val="lt1"/>
-          </a:fontRef>
-        </p:style>
-        <p:txBody>
-          <a:bodyPr rtlCol="0" anchor="ctr"/>
-          <a:lstStyle/>
-          <a:p>
-            <a:pPr algn="ctr"/>
-          </a:p>
-        </p:txBody>
-      </p:sp>
-      <p:sp>
-        <p:nvSpPr>
-          <p:cNvPr id="14" name="Rectangle 13"/>
-          <p:cNvSpPr/>
-          <p:nvPr/>
-        </p:nvSpPr>
-        <p:spPr>
-          <a:xfrm>
-            <a:off x="7114032" y="1197864"/>
-            <a:ext cx="4709160" cy="41148"/>
-          </a:xfrm>
-          <a:prstGeom prst="rect">
-            <a:avLst/>
-          </a:prstGeom>
-          <a:solidFill>
-            <a:srgbClr val="C82036"/>
-          </a:solidFill>
-          <a:ln>
-            <a:noFill/>
-          </a:ln>
-        </p:spPr>
-        <p:style>
-          <a:lnRef idx="1">
-            <a:schemeClr val="accent1"/>
-          </a:lnRef>
-          <a:fillRef idx="3">
-            <a:schemeClr val="accent1"/>
-          </a:fillRef>
-          <a:effectRef idx="2">
-            <a:schemeClr val="accent1"/>
-          </a:effectRef>
-          <a:fontRef idx="minor">
-            <a:schemeClr val="lt1"/>
-          </a:fontRef>
-        </p:style>
-        <p:txBody>
-          <a:bodyPr rtlCol="0" anchor="ctr"/>
-          <a:lstStyle/>
-          <a:p>
-            <a:pPr algn="ctr"/>
-          </a:p>
-        </p:txBody>
-      </p:sp>
-      <p:sp>
-        <p:nvSpPr>
-          <p:cNvPr id="15" name="TextBox 14"/>
-          <p:cNvSpPr txBox="1"/>
-          <p:nvPr/>
-        </p:nvSpPr>
-        <p:spPr>
-          <a:xfrm>
-            <a:off x="7306056" y="1426464"/>
-            <a:ext cx="4343400" cy="228600"/>
-          </a:xfrm>
-          <a:prstGeom prst="rect">
-            <a:avLst/>
-          </a:prstGeom>
-          <a:noFill/>
-        </p:spPr>
-        <p:txBody>
-          <a:bodyPr wrap="none" lIns="0" rIns="0" tIns="0" bIns="0" anchor="ctr">
-            <a:spAutoFit/>
-          </a:bodyPr>
-          <a:lstStyle/>
-          <a:p>
-            <a:pPr algn="l">
-              <a:spcBef>
-                <a:spcPts val="0"/>
-              </a:spcBef>
-              <a:spcAft>
-                <a:spcPts val="0"/>
-              </a:spcAft>
-            </a:pPr>
-            <a:r>
-              <a:rPr sz="1100" b="1">
-                <a:solidFill>
-                  <a:srgbClr val="F7F8F6"/>
-                </a:solidFill>
-                <a:latin typeface="Arial"/>
-              </a:rPr>
-              <a:t>BENCHMARK LOSS EVENTS</a:t>
-            </a:r>
-          </a:p>
-        </p:txBody>
-      </p:sp>
-      <p:sp>
-        <p:nvSpPr>
-          <p:cNvPr id="16" name="TextBox 15"/>
-          <p:cNvSpPr txBox="1"/>
-          <p:nvPr/>
-        </p:nvSpPr>
-        <p:spPr>
-          <a:xfrm>
-            <a:off x="7306056" y="1700784"/>
-            <a:ext cx="4343400" cy="182880"/>
-          </a:xfrm>
-          <a:prstGeom prst="rect">
-            <a:avLst/>
-          </a:prstGeom>
-          <a:noFill/>
-        </p:spPr>
-        <p:txBody>
-          <a:bodyPr wrap="none" lIns="0" rIns="0" tIns="0" bIns="0" anchor="ctr">
-            <a:spAutoFit/>
-          </a:bodyPr>
-          <a:lstStyle/>
-          <a:p>
-            <a:pPr algn="l">
-              <a:spcBef>
-                <a:spcPts val="0"/>
-              </a:spcBef>
-              <a:spcAft>
-                <a:spcPts val="0"/>
-              </a:spcAft>
-            </a:pPr>
-            <a:r>
-              <a:rPr sz="819" b="0">
-                <a:solidFill>
-                  <a:srgbClr val="A9B0B2"/>
-                </a:solidFill>
-                <a:latin typeface="Arial"/>
-              </a:rPr>
-              <a:t>Selected European trading-loss cases</a:t>
-            </a:r>
-          </a:p>
-        </p:txBody>
-      </p:sp>
-      <p:sp>
-        <p:nvSpPr>
-          <p:cNvPr id="17" name="Rectangle 16"/>
-          <p:cNvSpPr/>
-          <p:nvPr/>
-        </p:nvSpPr>
-        <p:spPr>
-          <a:xfrm>
-            <a:off x="7306056" y="1965960"/>
-            <a:ext cx="4325112" cy="7315"/>
-          </a:xfrm>
-          <a:prstGeom prst="rect">
-            <a:avLst/>
-          </a:prstGeom>
-          <a:solidFill>
-            <a:srgbClr val="30373B"/>
-          </a:solidFill>
-          <a:ln>
-            <a:noFill/>
-          </a:ln>
-        </p:spPr>
-        <p:style>
-          <a:lnRef idx="1">
-            <a:schemeClr val="accent1"/>
-          </a:lnRef>
-          <a:fillRef idx="3">
-            <a:schemeClr val="accent1"/>
-          </a:fillRef>
-          <a:effectRef idx="2">
-            <a:schemeClr val="accent1"/>
-          </a:effectRef>
-          <a:fontRef idx="minor">
-            <a:schemeClr val="lt1"/>
-          </a:fontRef>
-        </p:style>
-        <p:txBody>
-          <a:bodyPr rtlCol="0" anchor="ctr"/>
-          <a:lstStyle/>
-          <a:p>
-            <a:pPr algn="ctr"/>
-          </a:p>
-        </p:txBody>
-      </p:sp>
-      <p:sp>
-        <p:nvSpPr>
-          <p:cNvPr id="18" name="TextBox 17"/>
-          <p:cNvSpPr txBox="1"/>
-          <p:nvPr/>
-        </p:nvSpPr>
-        <p:spPr>
-          <a:xfrm>
-            <a:off x="7324344" y="2157984"/>
-            <a:ext cx="2487168" cy="210312"/>
-          </a:xfrm>
-          <a:prstGeom prst="rect">
-            <a:avLst/>
-          </a:prstGeom>
-          <a:noFill/>
-        </p:spPr>
-        <p:txBody>
-          <a:bodyPr wrap="none" lIns="0" rIns="0" tIns="0" bIns="0" anchor="ctr">
-            <a:spAutoFit/>
-          </a:bodyPr>
-          <a:lstStyle/>
-          <a:p>
-            <a:pPr algn="l">
-              <a:spcBef>
-                <a:spcPts val="0"/>
-              </a:spcBef>
-              <a:spcAft>
-                <a:spcPts val="0"/>
-              </a:spcAft>
-            </a:pPr>
-            <a:r>
-              <a:rPr sz="1000" b="1">
-                <a:solidFill>
-                  <a:srgbClr val="F7F8F6"/>
-                </a:solidFill>
-                <a:latin typeface="Arial"/>
-              </a:rPr>
-              <a:t>BARINGS</a:t>
-            </a:r>
-          </a:p>
-        </p:txBody>
-      </p:sp>
-      <p:sp>
-        <p:nvSpPr>
-          <p:cNvPr id="19" name="TextBox 18"/>
-          <p:cNvSpPr txBox="1"/>
-          <p:nvPr/>
-        </p:nvSpPr>
-        <p:spPr>
-          <a:xfrm>
-            <a:off x="11036808" y="2157984"/>
-            <a:ext cx="502920" cy="210312"/>
-          </a:xfrm>
-          <a:prstGeom prst="rect">
-            <a:avLst/>
-          </a:prstGeom>
-          <a:noFill/>
-        </p:spPr>
-        <p:txBody>
-          <a:bodyPr wrap="none" lIns="0" rIns="0" tIns="0" bIns="0" anchor="ctr">
-            <a:spAutoFit/>
-          </a:bodyPr>
-          <a:lstStyle/>
-          <a:p>
-            <a:pPr algn="r">
-              <a:spcBef>
-                <a:spcPts val="0"/>
-              </a:spcBef>
-              <a:spcAft>
-                <a:spcPts val="0"/>
-              </a:spcAft>
-            </a:pPr>
-            <a:r>
-              <a:rPr sz="900" b="1">
-                <a:solidFill>
-                  <a:srgbClr val="D6A600"/>
-                </a:solidFill>
-                <a:latin typeface="Arial"/>
-              </a:rPr>
-              <a:t>1995</a:t>
-            </a:r>
-          </a:p>
-        </p:txBody>
-      </p:sp>
-      <p:sp>
-        <p:nvSpPr>
-          <p:cNvPr id="20" name="TextBox 19"/>
-          <p:cNvSpPr txBox="1"/>
-          <p:nvPr/>
-        </p:nvSpPr>
-        <p:spPr>
-          <a:xfrm>
-            <a:off x="7324344" y="2414015"/>
-            <a:ext cx="2359152" cy="347472"/>
-          </a:xfrm>
-          <a:prstGeom prst="rect">
-            <a:avLst/>
-          </a:prstGeom>
-          <a:noFill/>
-        </p:spPr>
-        <p:txBody>
-          <a:bodyPr wrap="none" lIns="0" rIns="0" tIns="0" bIns="0" anchor="ctr">
-            <a:spAutoFit/>
-          </a:bodyPr>
-          <a:lstStyle/>
-          <a:p>
-            <a:pPr algn="l">
-              <a:spcBef>
-                <a:spcPts val="0"/>
-              </a:spcBef>
-              <a:spcAft>
-                <a:spcPts val="0"/>
-              </a:spcAft>
-            </a:pPr>
-            <a:r>
-              <a:rPr sz="1800" b="1">
-                <a:solidFill>
-                  <a:srgbClr val="D6A600"/>
-                </a:solidFill>
-                <a:latin typeface="Arial"/>
-              </a:rPr>
-              <a:t>USD -1.4bn</a:t>
-            </a:r>
-          </a:p>
-        </p:txBody>
-      </p:sp>
-      <p:sp>
-        <p:nvSpPr>
-          <p:cNvPr id="21" name="Rectangle 20"/>
-          <p:cNvSpPr/>
-          <p:nvPr/>
-        </p:nvSpPr>
-        <p:spPr>
-          <a:xfrm>
-            <a:off x="7306056" y="2907792"/>
-            <a:ext cx="4325112" cy="7315"/>
-          </a:xfrm>
-          <a:prstGeom prst="rect">
-            <a:avLst/>
-          </a:prstGeom>
-          <a:solidFill>
-            <a:srgbClr val="30373B"/>
-          </a:solidFill>
-          <a:ln>
-            <a:noFill/>
-          </a:ln>
-        </p:spPr>
-        <p:style>
-          <a:lnRef idx="1">
-            <a:schemeClr val="accent1"/>
-          </a:lnRef>
-          <a:fillRef idx="3">
-            <a:schemeClr val="accent1"/>
-          </a:fillRef>
-          <a:effectRef idx="2">
-            <a:schemeClr val="accent1"/>
-          </a:effectRef>
-          <a:fontRef idx="minor">
-            <a:schemeClr val="lt1"/>
-          </a:fontRef>
-        </p:style>
-        <p:txBody>
-          <a:bodyPr rtlCol="0" anchor="ctr"/>
-          <a:lstStyle/>
-          <a:p>
-            <a:pPr algn="ctr"/>
-          </a:p>
-        </p:txBody>
-      </p:sp>
-      <p:sp>
-        <p:nvSpPr>
-          <p:cNvPr id="22" name="TextBox 21"/>
-          <p:cNvSpPr txBox="1"/>
-          <p:nvPr/>
-        </p:nvSpPr>
-        <p:spPr>
-          <a:xfrm>
-            <a:off x="7324344" y="3090672"/>
-            <a:ext cx="2487168" cy="210312"/>
-          </a:xfrm>
-          <a:prstGeom prst="rect">
-            <a:avLst/>
-          </a:prstGeom>
-          <a:noFill/>
-        </p:spPr>
-        <p:txBody>
-          <a:bodyPr wrap="none" lIns="0" rIns="0" tIns="0" bIns="0" anchor="ctr">
-            <a:spAutoFit/>
-          </a:bodyPr>
-          <a:lstStyle/>
-          <a:p>
-            <a:pPr algn="l">
-              <a:spcBef>
-                <a:spcPts val="0"/>
-              </a:spcBef>
-              <a:spcAft>
-                <a:spcPts val="0"/>
-              </a:spcAft>
-            </a:pPr>
-            <a:r>
-              <a:rPr sz="1000" b="1">
-                <a:solidFill>
-                  <a:srgbClr val="F7F8F6"/>
-                </a:solidFill>
-                <a:latin typeface="Arial"/>
-              </a:rPr>
-              <a:t>KERVIEL</a:t>
-            </a:r>
-          </a:p>
-        </p:txBody>
-      </p:sp>
-      <p:sp>
-        <p:nvSpPr>
-          <p:cNvPr id="23" name="TextBox 22"/>
-          <p:cNvSpPr txBox="1"/>
-          <p:nvPr/>
-        </p:nvSpPr>
-        <p:spPr>
-          <a:xfrm>
-            <a:off x="11036808" y="3090672"/>
-            <a:ext cx="502920" cy="210312"/>
-          </a:xfrm>
-          <a:prstGeom prst="rect">
-            <a:avLst/>
-          </a:prstGeom>
-          <a:noFill/>
-        </p:spPr>
-        <p:txBody>
-          <a:bodyPr wrap="none" lIns="0" rIns="0" tIns="0" bIns="0" anchor="ctr">
-            <a:spAutoFit/>
-          </a:bodyPr>
-          <a:lstStyle/>
-          <a:p>
-            <a:pPr algn="r">
-              <a:spcBef>
-                <a:spcPts val="0"/>
-              </a:spcBef>
-              <a:spcAft>
-                <a:spcPts val="0"/>
-              </a:spcAft>
-            </a:pPr>
-            <a:r>
-              <a:rPr sz="900" b="1">
-                <a:solidFill>
-                  <a:srgbClr val="C82036"/>
-                </a:solidFill>
-                <a:latin typeface="Arial"/>
-              </a:rPr>
-              <a:t>2008</a:t>
-            </a:r>
-          </a:p>
-        </p:txBody>
-      </p:sp>
-      <p:sp>
-        <p:nvSpPr>
-          <p:cNvPr id="24" name="TextBox 23"/>
-          <p:cNvSpPr txBox="1"/>
-          <p:nvPr/>
-        </p:nvSpPr>
-        <p:spPr>
-          <a:xfrm>
-            <a:off x="7324344" y="3346704"/>
-            <a:ext cx="2359152" cy="347472"/>
-          </a:xfrm>
-          <a:prstGeom prst="rect">
-            <a:avLst/>
-          </a:prstGeom>
-          <a:noFill/>
-        </p:spPr>
-        <p:txBody>
-          <a:bodyPr wrap="none" lIns="0" rIns="0" tIns="0" bIns="0" anchor="ctr">
-            <a:spAutoFit/>
-          </a:bodyPr>
-          <a:lstStyle/>
-          <a:p>
-            <a:pPr algn="l">
-              <a:spcBef>
-                <a:spcPts val="0"/>
-              </a:spcBef>
-              <a:spcAft>
-                <a:spcPts val="0"/>
-              </a:spcAft>
-            </a:pPr>
-            <a:r>
-              <a:rPr sz="1800" b="1">
-                <a:solidFill>
-                  <a:srgbClr val="C82036"/>
-                </a:solidFill>
-                <a:latin typeface="Arial"/>
-              </a:rPr>
-              <a:t>EUR -4.9bn</a:t>
-            </a:r>
-          </a:p>
-        </p:txBody>
-      </p:sp>
-      <p:sp>
-        <p:nvSpPr>
-          <p:cNvPr id="25" name="TextBox 24"/>
-          <p:cNvSpPr txBox="1"/>
-          <p:nvPr/>
-        </p:nvSpPr>
-        <p:spPr>
-          <a:xfrm>
-            <a:off x="9720072" y="3401568"/>
-            <a:ext cx="1883663" cy="219456"/>
-          </a:xfrm>
-          <a:prstGeom prst="rect">
-            <a:avLst/>
-          </a:prstGeom>
-          <a:noFill/>
-        </p:spPr>
-        <p:txBody>
-          <a:bodyPr wrap="none" lIns="0" rIns="0" tIns="0" bIns="0" anchor="ctr">
-            <a:spAutoFit/>
-          </a:bodyPr>
-          <a:lstStyle/>
-          <a:p>
-            <a:pPr algn="r">
-              <a:spcBef>
-                <a:spcPts val="0"/>
-              </a:spcBef>
-              <a:spcAft>
-                <a:spcPts val="0"/>
-              </a:spcAft>
-            </a:pPr>
-            <a:r>
-              <a:rPr sz="850" b="0">
-                <a:solidFill>
-                  <a:srgbClr val="A9B0B2"/>
-                </a:solidFill>
-                <a:latin typeface="Arial"/>
-              </a:rPr>
-              <a:t>Société Générale</a:t>
-            </a:r>
-          </a:p>
-        </p:txBody>
-      </p:sp>
-      <p:sp>
-        <p:nvSpPr>
-          <p:cNvPr id="26" name="Rectangle 25"/>
-          <p:cNvSpPr/>
-          <p:nvPr/>
-        </p:nvSpPr>
-        <p:spPr>
-          <a:xfrm>
-            <a:off x="7306056" y="3840480"/>
-            <a:ext cx="4325112" cy="7315"/>
-          </a:xfrm>
-          <a:prstGeom prst="rect">
-            <a:avLst/>
-          </a:prstGeom>
-          <a:solidFill>
-            <a:srgbClr val="30373B"/>
-          </a:solidFill>
-          <a:ln>
-            <a:noFill/>
-          </a:ln>
-        </p:spPr>
-        <p:style>
-          <a:lnRef idx="1">
-            <a:schemeClr val="accent1"/>
-          </a:lnRef>
-          <a:fillRef idx="3">
-            <a:schemeClr val="accent1"/>
-          </a:fillRef>
-          <a:effectRef idx="2">
-            <a:schemeClr val="accent1"/>
-          </a:effectRef>
-          <a:fontRef idx="minor">
-            <a:schemeClr val="lt1"/>
-          </a:fontRef>
-        </p:style>
-        <p:txBody>
-          <a:bodyPr rtlCol="0" anchor="ctr"/>
-          <a:lstStyle/>
-          <a:p>
-            <a:pPr algn="ctr"/>
-          </a:p>
-        </p:txBody>
-      </p:sp>
-      <p:sp>
-        <p:nvSpPr>
-          <p:cNvPr id="27" name="TextBox 26"/>
-          <p:cNvSpPr txBox="1"/>
-          <p:nvPr/>
-        </p:nvSpPr>
-        <p:spPr>
-          <a:xfrm>
-            <a:off x="7324344" y="4023360"/>
-            <a:ext cx="2487168" cy="210312"/>
-          </a:xfrm>
-          <a:prstGeom prst="rect">
-            <a:avLst/>
-          </a:prstGeom>
-          <a:noFill/>
-        </p:spPr>
-        <p:txBody>
-          <a:bodyPr wrap="none" lIns="0" rIns="0" tIns="0" bIns="0" anchor="ctr">
-            <a:spAutoFit/>
-          </a:bodyPr>
-          <a:lstStyle/>
-          <a:p>
-            <a:pPr algn="l">
-              <a:spcBef>
-                <a:spcPts val="0"/>
-              </a:spcBef>
-              <a:spcAft>
-                <a:spcPts val="0"/>
-              </a:spcAft>
-            </a:pPr>
-            <a:r>
-              <a:rPr sz="1000" b="1">
-                <a:solidFill>
-                  <a:srgbClr val="F7F8F6"/>
-                </a:solidFill>
-                <a:latin typeface="Arial"/>
-              </a:rPr>
-              <a:t>ADOBOLI</a:t>
-            </a:r>
-          </a:p>
-        </p:txBody>
-      </p:sp>
-      <p:sp>
-        <p:nvSpPr>
-          <p:cNvPr id="28" name="TextBox 27"/>
-          <p:cNvSpPr txBox="1"/>
-          <p:nvPr/>
-        </p:nvSpPr>
-        <p:spPr>
-          <a:xfrm>
-            <a:off x="11036808" y="4023360"/>
-            <a:ext cx="502920" cy="210312"/>
-          </a:xfrm>
-          <a:prstGeom prst="rect">
-            <a:avLst/>
-          </a:prstGeom>
-          <a:noFill/>
-        </p:spPr>
-        <p:txBody>
-          <a:bodyPr wrap="none" lIns="0" rIns="0" tIns="0" bIns="0" anchor="ctr">
-            <a:spAutoFit/>
-          </a:bodyPr>
-          <a:lstStyle/>
-          <a:p>
-            <a:pPr algn="r">
-              <a:spcBef>
-                <a:spcPts val="0"/>
-              </a:spcBef>
-              <a:spcAft>
-                <a:spcPts val="0"/>
-              </a:spcAft>
-            </a:pPr>
-            <a:r>
-              <a:rPr sz="900" b="1">
-                <a:solidFill>
-                  <a:srgbClr val="C82036"/>
-                </a:solidFill>
-                <a:latin typeface="Arial"/>
-              </a:rPr>
-              <a:t>2011</a:t>
-            </a:r>
-          </a:p>
-        </p:txBody>
-      </p:sp>
-      <p:sp>
-        <p:nvSpPr>
-          <p:cNvPr id="29" name="TextBox 28"/>
-          <p:cNvSpPr txBox="1"/>
-          <p:nvPr/>
-        </p:nvSpPr>
-        <p:spPr>
-          <a:xfrm>
-            <a:off x="7324344" y="4279392"/>
-            <a:ext cx="2359152" cy="347472"/>
-          </a:xfrm>
-          <a:prstGeom prst="rect">
-            <a:avLst/>
-          </a:prstGeom>
-          <a:noFill/>
-        </p:spPr>
-        <p:txBody>
-          <a:bodyPr wrap="none" lIns="0" rIns="0" tIns="0" bIns="0" anchor="ctr">
-            <a:spAutoFit/>
-          </a:bodyPr>
-          <a:lstStyle/>
-          <a:p>
-            <a:pPr algn="l">
-              <a:spcBef>
-                <a:spcPts val="0"/>
-              </a:spcBef>
-              <a:spcAft>
-                <a:spcPts val="0"/>
-              </a:spcAft>
-            </a:pPr>
-            <a:r>
-              <a:rPr sz="1800" b="1">
-                <a:solidFill>
-                  <a:srgbClr val="C82036"/>
-                </a:solidFill>
-                <a:latin typeface="Arial"/>
-              </a:rPr>
-              <a:t>USD -2.3bn</a:t>
-            </a:r>
-          </a:p>
-        </p:txBody>
-      </p:sp>
-      <p:sp>
-        <p:nvSpPr>
-          <p:cNvPr id="30" name="TextBox 29"/>
-          <p:cNvSpPr txBox="1"/>
-          <p:nvPr/>
-        </p:nvSpPr>
-        <p:spPr>
-          <a:xfrm>
-            <a:off x="9720072" y="4334256"/>
-            <a:ext cx="1883663" cy="219456"/>
-          </a:xfrm>
-          <a:prstGeom prst="rect">
-            <a:avLst/>
-          </a:prstGeom>
-          <a:noFill/>
-        </p:spPr>
-        <p:txBody>
-          <a:bodyPr wrap="none" lIns="0" rIns="0" tIns="0" bIns="0" anchor="ctr">
-            <a:spAutoFit/>
-          </a:bodyPr>
-          <a:lstStyle/>
-          <a:p>
-            <a:pPr algn="r">
-              <a:spcBef>
-                <a:spcPts val="0"/>
-              </a:spcBef>
-              <a:spcAft>
-                <a:spcPts val="0"/>
-              </a:spcAft>
-            </a:pPr>
-            <a:r>
-              <a:rPr sz="850" b="0">
-                <a:solidFill>
-                  <a:srgbClr val="A9B0B2"/>
-                </a:solidFill>
-                <a:latin typeface="Arial"/>
-              </a:rPr>
-              <a:t>UBS</a:t>
-            </a:r>
-          </a:p>
-        </p:txBody>
-      </p:sp>
-      <p:sp>
-        <p:nvSpPr>
-          <p:cNvPr id="31" name="Rectangle 30"/>
-          <p:cNvSpPr/>
-          <p:nvPr/>
-        </p:nvSpPr>
-        <p:spPr>
-          <a:xfrm>
-            <a:off x="7306056" y="4773168"/>
-            <a:ext cx="4325112" cy="7315"/>
-          </a:xfrm>
-          <a:prstGeom prst="rect">
-            <a:avLst/>
-          </a:prstGeom>
-          <a:solidFill>
-            <a:srgbClr val="30373B"/>
-          </a:solidFill>
-          <a:ln>
-            <a:noFill/>
-          </a:ln>
-        </p:spPr>
-        <p:style>
-          <a:lnRef idx="1">
-            <a:schemeClr val="accent1"/>
-          </a:lnRef>
-          <a:fillRef idx="3">
-            <a:schemeClr val="accent1"/>
-          </a:fillRef>
-          <a:effectRef idx="2">
-            <a:schemeClr val="accent1"/>
-          </a:effectRef>
-          <a:fontRef idx="minor">
-            <a:schemeClr val="lt1"/>
-          </a:fontRef>
-        </p:style>
-        <p:txBody>
-          <a:bodyPr rtlCol="0" anchor="ctr"/>
-          <a:lstStyle/>
-          <a:p>
-            <a:pPr algn="ctr"/>
-          </a:p>
-        </p:txBody>
-      </p:sp>
-      <p:sp>
-        <p:nvSpPr>
-          <p:cNvPr id="32" name="TextBox 31"/>
-          <p:cNvSpPr txBox="1"/>
-          <p:nvPr/>
-        </p:nvSpPr>
-        <p:spPr>
-          <a:xfrm>
-            <a:off x="7324344" y="4965192"/>
-            <a:ext cx="4251960" cy="182880"/>
-          </a:xfrm>
-          <a:prstGeom prst="rect">
-            <a:avLst/>
-          </a:prstGeom>
-          <a:noFill/>
-        </p:spPr>
-        <p:txBody>
-          <a:bodyPr wrap="none" lIns="0" rIns="0" tIns="0" bIns="0" anchor="ctr">
-            <a:spAutoFit/>
-          </a:bodyPr>
-          <a:lstStyle/>
-          <a:p>
-            <a:pPr algn="l">
-              <a:spcBef>
-                <a:spcPts val="0"/>
-              </a:spcBef>
-              <a:spcAft>
-                <a:spcPts val="0"/>
-              </a:spcAft>
-            </a:pPr>
-            <a:r>
-              <a:rPr sz="819" b="1">
-                <a:solidFill>
-                  <a:srgbClr val="D6A600"/>
-                </a:solidFill>
-                <a:latin typeface="Arial"/>
-              </a:rPr>
-              <a:t>LOCATION NOTE</a:t>
-            </a:r>
-          </a:p>
-        </p:txBody>
-      </p:sp>
-      <p:sp>
-        <p:nvSpPr>
-          <p:cNvPr id="33" name="TextBox 32"/>
-          <p:cNvSpPr txBox="1"/>
-          <p:nvPr/>
-        </p:nvSpPr>
-        <p:spPr>
-          <a:xfrm>
-            <a:off x="7324344" y="5212080"/>
-            <a:ext cx="4251960" cy="219456"/>
-          </a:xfrm>
-          <a:prstGeom prst="rect">
-            <a:avLst/>
-          </a:prstGeom>
-          <a:noFill/>
-        </p:spPr>
-        <p:txBody>
-          <a:bodyPr wrap="none" lIns="0" rIns="0" tIns="0" bIns="0" anchor="ctr">
-            <a:spAutoFit/>
-          </a:bodyPr>
-          <a:lstStyle/>
-          <a:p>
-            <a:pPr algn="l">
-              <a:spcBef>
-                <a:spcPts val="0"/>
-              </a:spcBef>
-              <a:spcAft>
-                <a:spcPts val="0"/>
-              </a:spcAft>
-            </a:pPr>
-            <a:r>
-              <a:rPr sz="1000" b="1">
-                <a:solidFill>
-                  <a:srgbClr val="F7F8F6"/>
-                </a:solidFill>
-                <a:latin typeface="Arial"/>
-              </a:rPr>
-              <a:t>Adoboli's trading desk: London</a:t>
-            </a:r>
-          </a:p>
-        </p:txBody>
-      </p:sp>
-      <p:sp>
-        <p:nvSpPr>
-          <p:cNvPr id="34" name="TextBox 33"/>
-          <p:cNvSpPr txBox="1"/>
-          <p:nvPr/>
-        </p:nvSpPr>
-        <p:spPr>
-          <a:xfrm>
-            <a:off x="7324344" y="5477256"/>
-            <a:ext cx="4251960" cy="210312"/>
-          </a:xfrm>
-          <a:prstGeom prst="rect">
-            <a:avLst/>
-          </a:prstGeom>
-          <a:noFill/>
-        </p:spPr>
-        <p:txBody>
-          <a:bodyPr wrap="none" lIns="0" rIns="0" tIns="0" bIns="0" anchor="ctr">
-            <a:spAutoFit/>
-          </a:bodyPr>
-          <a:lstStyle/>
-          <a:p>
-            <a:pPr algn="l">
-              <a:spcBef>
-                <a:spcPts val="0"/>
-              </a:spcBef>
-              <a:spcAft>
-                <a:spcPts val="0"/>
-              </a:spcAft>
-            </a:pPr>
-            <a:r>
-              <a:rPr sz="900" b="0">
-                <a:solidFill>
-                  <a:srgbClr val="A9B0B2"/>
-                </a:solidFill>
-                <a:latin typeface="Arial"/>
-              </a:rPr>
-              <a:t>UBS Group headquarters: Zurich</a:t>
-            </a:r>
-          </a:p>
-        </p:txBody>
-      </p:sp>
-      <p:sp>
-        <p:nvSpPr>
-          <p:cNvPr id="35" name="Rectangle 34"/>
-          <p:cNvSpPr/>
-          <p:nvPr/>
-        </p:nvSpPr>
-        <p:spPr>
-          <a:xfrm>
-            <a:off x="384048" y="6291072"/>
+            <a:off x="384048" y="6318504"/>
             <a:ext cx="11439144" cy="10972"/>
           </a:xfrm>
           <a:prstGeom prst="rect">
@@ -4486,13 +3382,13 @@
       </p:sp>
       <p:sp>
         <p:nvSpPr>
-          <p:cNvPr id="36" name="TextBox 35"/>
+          <p:cNvPr id="10" name="TextBox 9"/>
           <p:cNvSpPr txBox="1"/>
           <p:nvPr/>
         </p:nvSpPr>
         <p:spPr>
           <a:xfrm>
-            <a:off x="402336" y="6373368"/>
+            <a:off x="402336" y="6391656"/>
             <a:ext cx="1444752" cy="164592"/>
           </a:xfrm>
           <a:prstGeom prst="rect">
@@ -4528,13 +3424,13 @@
       </p:sp>
       <p:sp>
         <p:nvSpPr>
-          <p:cNvPr id="37" name="TextBox 36"/>
+          <p:cNvPr id="11" name="TextBox 10"/>
           <p:cNvSpPr txBox="1"/>
           <p:nvPr/>
         </p:nvSpPr>
         <p:spPr>
           <a:xfrm>
-            <a:off x="1847088" y="6355080"/>
+            <a:off x="1847088" y="6373368"/>
             <a:ext cx="9829800" cy="210312"/>
           </a:xfrm>
           <a:prstGeom prst="rect">
@@ -4570,13 +3466,13 @@
       </p:sp>
       <p:sp>
         <p:nvSpPr>
-          <p:cNvPr id="38" name="TextBox 37"/>
+          <p:cNvPr id="12" name="TextBox 11"/>
           <p:cNvSpPr txBox="1"/>
           <p:nvPr/>
         </p:nvSpPr>
         <p:spPr>
           <a:xfrm>
-            <a:off x="10899648" y="6638544"/>
+            <a:off x="10899648" y="6647688"/>
             <a:ext cx="868680" cy="109728"/>
           </a:xfrm>
           <a:prstGeom prst="rect">

</xml_diff>